<commit_message>
feat: update final presentation to a single student persona
</commit_message>
<xml_diff>
--- a/Abschlusspräsentation/ThesisFlow_Abschlusspraesentation.pptx
+++ b/Abschlusspräsentation/ThesisFlow_Abschlusspraesentation.pptx
@@ -13738,7 +13738,7 @@
       </p:sp>
       <p:pic>
         <p:nvPicPr>
-          <p:cNvPr id="11" name="Image 0" descr="C:\Users\Ewa\OneDrive - Aurora Engineering GmbH\ZXY\Desktop\Studium\Requirement Eng\Abschlusspräsentation\bilder\master.png">    </p:cNvPr>
+          <p:cNvPr id="11" name="Image 0" descr="C:\Users\Ewa\OneDrive - Aurora Engineering GmbH\ZXY\Desktop\Studium\Requirement Eng\Abschlusspräsentation\bilder\bachelor.png">    </p:cNvPr>
           <p:cNvPicPr>
             <a:picLocks noChangeAspect="1"/>
           </p:cNvPicPr>
@@ -13752,10 +13752,10 @@
         </p:blipFill>
         <p:spPr>
           <a:xfrm>
-            <a:off x="457200" y="2697480"/>
-            <a:ext cx="731520" cy="731520"/>
-          </a:xfrm>
-          <a:prstGeom prst="ellipse">
+            <a:off x="594360" y="2651760"/>
+            <a:ext cx="374073" cy="868680"/>
+          </a:xfrm>
+          <a:prstGeom prst="rect">
             <a:avLst/>
           </a:prstGeom>
         </p:spPr>
@@ -13793,7 +13793,7 @@
                 <a:ea typeface="Calibri" pitchFamily="34" charset="-122"/>
                 <a:cs typeface="Calibri" pitchFamily="34" charset="-120"/>
               </a:rPr>
-              <a:t>Tarek Yilmaz</a:t>
+              <a:t>Moritz Hoffmann</a:t>
             </a:r>
             <a:endParaRPr lang="en-US" sz="1000" dirty="0"/>
           </a:p>
@@ -13810,7 +13810,7 @@
                 <a:ea typeface="Calibri" pitchFamily="34" charset="-122"/>
                 <a:cs typeface="Calibri" pitchFamily="34" charset="-120"/>
               </a:rPr>
-              <a:t>Studierende:r, M.Sc. Wirtschaftsinformatik, berufsbegleitend</a:t>
+              <a:t>Studierende:r</a:t>
             </a:r>
             <a:endParaRPr lang="en-US" sz="1000" dirty="0"/>
           </a:p>
@@ -23719,7 +23719,7 @@
                 <a:ea typeface="Calibri" pitchFamily="34" charset="-122"/>
                 <a:cs typeface="Calibri" pitchFamily="34" charset="-120"/>
               </a:rPr>
-              <a:t>Vier Personas für die Rollen, die ThesisFlow nutzen</a:t>
+              <a:t>Drei Personas für die Rollen, die ThesisFlow nutzen</a:t>
             </a:r>
             <a:endParaRPr lang="en-US" sz="950" dirty="0"/>
           </a:p>
@@ -23812,11 +23812,11 @@
         <p:spPr>
           <a:xfrm>
             <a:off x="411480" y="932688"/>
-            <a:ext cx="1984248" cy="3063240"/>
+            <a:ext cx="2697480" cy="3063240"/>
           </a:xfrm>
           <a:prstGeom prst="roundRect">
             <a:avLst>
-              <a:gd name="adj" fmla="val 3687"/>
+              <a:gd name="adj" fmla="val 2712"/>
             </a:avLst>
           </a:prstGeom>
           <a:solidFill>
@@ -23846,7 +23846,7 @@
         </p:blipFill>
         <p:spPr>
           <a:xfrm>
-            <a:off x="1177192" y="1042416"/>
+            <a:off x="1533808" y="1042416"/>
             <a:ext cx="452825" cy="1051560"/>
           </a:xfrm>
           <a:prstGeom prst="rect">
@@ -23863,7 +23863,7 @@
         <p:spPr>
           <a:xfrm>
             <a:off x="484632" y="2167128"/>
-            <a:ext cx="1837944" cy="274320"/>
+            <a:ext cx="2551176" cy="274320"/>
           </a:xfrm>
           <a:prstGeom prst="rect">
             <a:avLst/>
@@ -23902,7 +23902,7 @@
         <p:spPr>
           <a:xfrm>
             <a:off x="484632" y="2441448"/>
-            <a:ext cx="1837944" cy="310896"/>
+            <a:ext cx="2551176" cy="310896"/>
           </a:xfrm>
           <a:prstGeom prst="rect">
             <a:avLst/>
@@ -23926,7 +23926,7 @@
                 <a:ea typeface="Calibri" pitchFamily="34" charset="-122"/>
                 <a:cs typeface="Calibri" pitchFamily="34" charset="-120"/>
               </a:rPr>
-              <a:t>Studierende:r, B.Sc. WI</a:t>
+              <a:t>Studierende:r</a:t>
             </a:r>
             <a:endParaRPr lang="en-US" sz="850" dirty="0"/>
           </a:p>
@@ -23941,7 +23941,7 @@
         <p:spPr>
           <a:xfrm>
             <a:off x="539496" y="2807208"/>
-            <a:ext cx="1728216" cy="548640"/>
+            <a:ext cx="2441448" cy="548640"/>
           </a:xfrm>
           <a:prstGeom prst="rect">
             <a:avLst/>
@@ -23979,7 +23979,7 @@
                 <a:ea typeface="Calibri" pitchFamily="34" charset="-122"/>
                 <a:cs typeface="Calibri" pitchFamily="34" charset="-120"/>
               </a:rPr>
-              <a:t>Antrag in einem Durchgang einreichen, Status jederzeit sehen</a:t>
+              <a:t>Antrag in einem Durchgang einreichen, Status jederzeit sehen, Verlängerung online beantragen</a:t>
             </a:r>
             <a:endParaRPr lang="en-US" sz="850" dirty="0"/>
           </a:p>
@@ -23994,7 +23994,7 @@
         <p:spPr>
           <a:xfrm>
             <a:off x="539496" y="3401568"/>
-            <a:ext cx="1728216" cy="548640"/>
+            <a:ext cx="2441448" cy="548640"/>
           </a:xfrm>
           <a:prstGeom prst="rect">
             <a:avLst/>
@@ -24032,7 +24032,7 @@
                 <a:ea typeface="Calibri" pitchFamily="34" charset="-122"/>
                 <a:cs typeface="Calibri" pitchFamily="34" charset="-120"/>
               </a:rPr>
-              <a:t>Wochenlang keine Rückmeldung zum Antrag</a:t>
+              <a:t>Wochenlang keine Rückmeldung zum Antrag, Papierformulare und unklare Fristen</a:t>
             </a:r>
             <a:endParaRPr lang="en-US" sz="850" dirty="0"/>
           </a:p>
@@ -24046,12 +24046,12 @@
         </p:nvSpPr>
         <p:spPr>
           <a:xfrm>
-            <a:off x="2523744" y="932688"/>
-            <a:ext cx="1984248" cy="3063240"/>
+            <a:off x="3223260" y="932688"/>
+            <a:ext cx="2697480" cy="3063240"/>
           </a:xfrm>
           <a:prstGeom prst="roundRect">
             <a:avLst>
-              <a:gd name="adj" fmla="val 3687"/>
+              <a:gd name="adj" fmla="val 2712"/>
             </a:avLst>
           </a:prstGeom>
           <a:solidFill>
@@ -24073,8 +24073,8 @@
         </p:nvSpPr>
         <p:spPr>
           <a:xfrm>
-            <a:off x="2999232" y="1051560"/>
-            <a:ext cx="1033272" cy="1033272"/>
+            <a:off x="4091940" y="1088136"/>
+            <a:ext cx="960120" cy="960120"/>
           </a:xfrm>
           <a:prstGeom prst="ellipse">
             <a:avLst/>
@@ -24090,41 +24090,17 @@
           </a:ln>
         </p:spPr>
       </p:sp>
-      <p:pic>
-        <p:nvPicPr>
-          <p:cNvPr id="15" name="Image 1" descr="C:\Users\Ewa\OneDrive - Aurora Engineering GmbH\ZXY\Desktop\Studium\Requirement Eng\Abschlusspräsentation\bilder\master.png">    </p:cNvPr>
-          <p:cNvPicPr>
-            <a:picLocks noChangeAspect="1"/>
-          </p:cNvPicPr>
-          <p:nvPr/>
-        </p:nvPicPr>
-        <p:blipFill>
-          <a:blip r:embed="rId2"/>
-          <a:stretch>
-            <a:fillRect/>
-          </a:stretch>
-        </p:blipFill>
-        <p:spPr>
-          <a:xfrm>
-            <a:off x="3035808" y="1088136"/>
+      <p:sp>
+        <p:nvSpPr>
+          <p:cNvPr id="15" name="Text 12"/>
+          <p:cNvSpPr txBox="1"/>
+          <p:nvPr/>
+        </p:nvSpPr>
+        <p:spPr>
+          <a:xfrm>
+            <a:off x="4091940" y="1088136"/>
             <a:ext cx="960120" cy="960120"/>
           </a:xfrm>
-          <a:prstGeom prst="ellipse">
-            <a:avLst/>
-          </a:prstGeom>
-        </p:spPr>
-      </p:pic>
-      <p:sp>
-        <p:nvSpPr>
-          <p:cNvPr id="16" name="Text 12"/>
-          <p:cNvSpPr txBox="1"/>
-          <p:nvPr/>
-        </p:nvSpPr>
-        <p:spPr>
-          <a:xfrm>
-            <a:off x="2596896" y="2167128"/>
-            <a:ext cx="1837944" cy="274320"/>
-          </a:xfrm>
           <a:prstGeom prst="rect">
             <a:avLst/>
           </a:prstGeom>
@@ -24139,15 +24115,54 @@
               <a:buNone/>
             </a:pPr>
             <a:r>
-              <a:rPr lang="en-US" sz="1150" b="1" dirty="0">
-                <a:solidFill>
-                  <a:srgbClr val="1F2A1F"/>
+              <a:rPr lang="en-US" sz="2400" b="1" dirty="0">
+                <a:solidFill>
+                  <a:srgbClr val="FFFFFF"/>
                 </a:solidFill>
                 <a:latin typeface="Cambria" pitchFamily="34" charset="0"/>
                 <a:ea typeface="Cambria" pitchFamily="34" charset="-122"/>
                 <a:cs typeface="Cambria" pitchFamily="34" charset="-120"/>
               </a:rPr>
-              <a:t>Tarek Yilmaz</a:t>
+              <a:t>AB</a:t>
+            </a:r>
+            <a:endParaRPr lang="en-US" sz="2400" dirty="0"/>
+          </a:p>
+        </p:txBody>
+      </p:sp>
+      <p:sp>
+        <p:nvSpPr>
+          <p:cNvPr id="16" name="Text 13"/>
+          <p:cNvSpPr txBox="1"/>
+          <p:nvPr/>
+        </p:nvSpPr>
+        <p:spPr>
+          <a:xfrm>
+            <a:off x="3296412" y="2167128"/>
+            <a:ext cx="2551176" cy="274320"/>
+          </a:xfrm>
+          <a:prstGeom prst="rect">
+            <a:avLst/>
+          </a:prstGeom>
+          <a:noFill/>
+          <a:ln/>
+        </p:spPr>
+        <p:txBody>
+          <a:bodyPr wrap="square" lIns="0" tIns="0" rIns="0" bIns="0" rtlCol="0" anchor="ctr"/>
+          <a:lstStyle/>
+          <a:p>
+            <a:pPr algn="ctr" indent="0" marL="0">
+              <a:buNone/>
+            </a:pPr>
+            <a:r>
+              <a:rPr lang="en-US" sz="1150" b="1" dirty="0">
+                <a:solidFill>
+                  <a:srgbClr val="1F2A1F"/>
+                </a:solidFill>
+                <a:latin typeface="Cambria" pitchFamily="34" charset="0"/>
+                <a:ea typeface="Cambria" pitchFamily="34" charset="-122"/>
+                <a:cs typeface="Cambria" pitchFamily="34" charset="-120"/>
+              </a:rPr>
+              <a:t>Prof. Dr. Andreas Becker</a:t>
             </a:r>
             <a:endParaRPr lang="en-US" sz="1150" dirty="0"/>
           </a:p>
@@ -24155,14 +24170,14 @@
       </p:sp>
       <p:sp>
         <p:nvSpPr>
-          <p:cNvPr id="17" name="Text 13"/>
-          <p:cNvSpPr txBox="1"/>
-          <p:nvPr/>
-        </p:nvSpPr>
-        <p:spPr>
-          <a:xfrm>
-            <a:off x="2596896" y="2441448"/>
-            <a:ext cx="1837944" cy="310896"/>
+          <p:cNvPr id="17" name="Text 14"/>
+          <p:cNvSpPr txBox="1"/>
+          <p:nvPr/>
+        </p:nvSpPr>
+        <p:spPr>
+          <a:xfrm>
+            <a:off x="3296412" y="2441448"/>
+            <a:ext cx="2551176" cy="310896"/>
           </a:xfrm>
           <a:prstGeom prst="rect">
             <a:avLst/>
@@ -24186,7 +24201,7 @@
                 <a:ea typeface="Calibri" pitchFamily="34" charset="-122"/>
                 <a:cs typeface="Calibri" pitchFamily="34" charset="-120"/>
               </a:rPr>
-              <a:t>Studierende:r, M.Sc. WI, berufsbegleitend</a:t>
+              <a:t>Erstprüfer:in</a:t>
             </a:r>
             <a:endParaRPr lang="en-US" sz="850" dirty="0"/>
           </a:p>
@@ -24194,14 +24209,14 @@
       </p:sp>
       <p:sp>
         <p:nvSpPr>
-          <p:cNvPr id="18" name="Text 14"/>
-          <p:cNvSpPr txBox="1"/>
-          <p:nvPr/>
-        </p:nvSpPr>
-        <p:spPr>
-          <a:xfrm>
-            <a:off x="2651760" y="2807208"/>
-            <a:ext cx="1728216" cy="548640"/>
+          <p:cNvPr id="18" name="Text 15"/>
+          <p:cNvSpPr txBox="1"/>
+          <p:nvPr/>
+        </p:nvSpPr>
+        <p:spPr>
+          <a:xfrm>
+            <a:off x="3351276" y="2807208"/>
+            <a:ext cx="2441448" cy="548640"/>
           </a:xfrm>
           <a:prstGeom prst="rect">
             <a:avLst/>
@@ -24239,7 +24254,7 @@
                 <a:ea typeface="Calibri" pitchFamily="34" charset="-122"/>
                 <a:cs typeface="Calibri" pitchFamily="34" charset="-120"/>
               </a:rPr>
-              <a:t>Externe Zweitprüfer:in einbinden, Verlängerung online beantragen</a:t>
+              <a:t>Thema prüfen und freigeben, ohne Formular und Unterschrift</a:t>
             </a:r>
             <a:endParaRPr lang="en-US" sz="850" dirty="0"/>
           </a:p>
@@ -24247,14 +24262,14 @@
       </p:sp>
       <p:sp>
         <p:nvSpPr>
-          <p:cNvPr id="19" name="Text 15"/>
-          <p:cNvSpPr txBox="1"/>
-          <p:nvPr/>
-        </p:nvSpPr>
-        <p:spPr>
-          <a:xfrm>
-            <a:off x="2651760" y="3401568"/>
-            <a:ext cx="1728216" cy="548640"/>
+          <p:cNvPr id="19" name="Text 16"/>
+          <p:cNvSpPr txBox="1"/>
+          <p:nvPr/>
+        </p:nvSpPr>
+        <p:spPr>
+          <a:xfrm>
+            <a:off x="3351276" y="3401568"/>
+            <a:ext cx="2441448" cy="548640"/>
           </a:xfrm>
           <a:prstGeom prst="rect">
             <a:avLst/>
@@ -24292,7 +24307,7 @@
                 <a:ea typeface="Calibri" pitchFamily="34" charset="-122"/>
                 <a:cs typeface="Calibri" pitchFamily="34" charset="-120"/>
               </a:rPr>
-              <a:t>Termine vor Ort kollidieren mit dem Beruf</a:t>
+              <a:t>Formular per E-Mail hin- und herschicken</a:t>
             </a:r>
             <a:endParaRPr lang="en-US" sz="850" dirty="0"/>
           </a:p>
@@ -24300,18 +24315,18 @@
       </p:sp>
       <p:sp>
         <p:nvSpPr>
-          <p:cNvPr id="20" name="Shape 16"/>
+          <p:cNvPr id="20" name="Shape 17"/>
           <p:cNvSpPr/>
           <p:nvPr/>
         </p:nvSpPr>
         <p:spPr>
           <a:xfrm>
-            <a:off x="4636008" y="932688"/>
-            <a:ext cx="1984248" cy="3063240"/>
+            <a:off x="6035040" y="932688"/>
+            <a:ext cx="2697480" cy="3063240"/>
           </a:xfrm>
           <a:prstGeom prst="roundRect">
             <a:avLst>
-              <a:gd name="adj" fmla="val 3687"/>
+              <a:gd name="adj" fmla="val 2712"/>
             </a:avLst>
           </a:prstGeom>
           <a:solidFill>
@@ -24327,14 +24342,14 @@
       </p:sp>
       <p:sp>
         <p:nvSpPr>
-          <p:cNvPr id="21" name="Shape 17"/>
+          <p:cNvPr id="21" name="Shape 18"/>
           <p:cNvSpPr/>
           <p:nvPr/>
         </p:nvSpPr>
         <p:spPr>
           <a:xfrm>
-            <a:off x="5148072" y="1088136"/>
-            <a:ext cx="960120" cy="960120"/>
+            <a:off x="6867144" y="1051560"/>
+            <a:ext cx="1033272" cy="1033272"/>
           </a:xfrm>
           <a:prstGeom prst="ellipse">
             <a:avLst/>
@@ -24350,298 +24365,23 @@
           </a:ln>
         </p:spPr>
       </p:sp>
-      <p:sp>
-        <p:nvSpPr>
-          <p:cNvPr id="22" name="Text 18"/>
-          <p:cNvSpPr txBox="1"/>
-          <p:nvPr/>
-        </p:nvSpPr>
-        <p:spPr>
-          <a:xfrm>
-            <a:off x="5148072" y="1088136"/>
-            <a:ext cx="960120" cy="960120"/>
-          </a:xfrm>
-          <a:prstGeom prst="rect">
-            <a:avLst/>
-          </a:prstGeom>
-          <a:noFill/>
-          <a:ln/>
-        </p:spPr>
-        <p:txBody>
-          <a:bodyPr wrap="square" lIns="0" tIns="0" rIns="0" bIns="0" rtlCol="0" anchor="ctr"/>
-          <a:lstStyle/>
-          <a:p>
-            <a:pPr algn="ctr" indent="0" marL="0">
-              <a:buNone/>
-            </a:pPr>
-            <a:r>
-              <a:rPr lang="en-US" sz="2400" b="1" dirty="0">
-                <a:solidFill>
-                  <a:srgbClr val="FFFFFF"/>
-                </a:solidFill>
-                <a:latin typeface="Cambria" pitchFamily="34" charset="0"/>
-                <a:ea typeface="Cambria" pitchFamily="34" charset="-122"/>
-                <a:cs typeface="Cambria" pitchFamily="34" charset="-120"/>
-              </a:rPr>
-              <a:t>AB</a:t>
-            </a:r>
-            <a:endParaRPr lang="en-US" sz="2400" dirty="0"/>
-          </a:p>
-        </p:txBody>
-      </p:sp>
-      <p:sp>
-        <p:nvSpPr>
-          <p:cNvPr id="23" name="Text 19"/>
-          <p:cNvSpPr txBox="1"/>
-          <p:nvPr/>
-        </p:nvSpPr>
-        <p:spPr>
-          <a:xfrm>
-            <a:off x="4709160" y="2167128"/>
-            <a:ext cx="1837944" cy="274320"/>
-          </a:xfrm>
-          <a:prstGeom prst="rect">
-            <a:avLst/>
-          </a:prstGeom>
-          <a:noFill/>
-          <a:ln/>
-        </p:spPr>
-        <p:txBody>
-          <a:bodyPr wrap="square" lIns="0" tIns="0" rIns="0" bIns="0" rtlCol="0" anchor="ctr"/>
-          <a:lstStyle/>
-          <a:p>
-            <a:pPr algn="ctr" indent="0" marL="0">
-              <a:buNone/>
-            </a:pPr>
-            <a:r>
-              <a:rPr lang="en-US" sz="1150" b="1" dirty="0">
-                <a:solidFill>
-                  <a:srgbClr val="1F2A1F"/>
-                </a:solidFill>
-                <a:latin typeface="Cambria" pitchFamily="34" charset="0"/>
-                <a:ea typeface="Cambria" pitchFamily="34" charset="-122"/>
-                <a:cs typeface="Cambria" pitchFamily="34" charset="-120"/>
-              </a:rPr>
-              <a:t>Prof. Dr. Andreas Becker</a:t>
-            </a:r>
-            <a:endParaRPr lang="en-US" sz="1150" dirty="0"/>
-          </a:p>
-        </p:txBody>
-      </p:sp>
-      <p:sp>
-        <p:nvSpPr>
-          <p:cNvPr id="24" name="Text 20"/>
-          <p:cNvSpPr txBox="1"/>
-          <p:nvPr/>
-        </p:nvSpPr>
-        <p:spPr>
-          <a:xfrm>
-            <a:off x="4709160" y="2441448"/>
-            <a:ext cx="1837944" cy="310896"/>
-          </a:xfrm>
-          <a:prstGeom prst="rect">
-            <a:avLst/>
-          </a:prstGeom>
-          <a:noFill/>
-          <a:ln/>
-        </p:spPr>
-        <p:txBody>
-          <a:bodyPr wrap="square" lIns="0" tIns="0" rIns="0" bIns="0" rtlCol="0" anchor="t"/>
-          <a:lstStyle/>
-          <a:p>
-            <a:pPr algn="ctr" indent="0" marL="0">
-              <a:buNone/>
-            </a:pPr>
-            <a:r>
-              <a:rPr lang="en-US" sz="850" dirty="0">
-                <a:solidFill>
-                  <a:srgbClr val="5C6B5C"/>
-                </a:solidFill>
-                <a:latin typeface="Calibri" pitchFamily="34" charset="0"/>
-                <a:ea typeface="Calibri" pitchFamily="34" charset="-122"/>
-                <a:cs typeface="Calibri" pitchFamily="34" charset="-120"/>
-              </a:rPr>
-              <a:t>Erstprüfer:in</a:t>
-            </a:r>
-            <a:endParaRPr lang="en-US" sz="850" dirty="0"/>
-          </a:p>
-        </p:txBody>
-      </p:sp>
-      <p:sp>
-        <p:nvSpPr>
-          <p:cNvPr id="25" name="Text 21"/>
-          <p:cNvSpPr txBox="1"/>
-          <p:nvPr/>
-        </p:nvSpPr>
-        <p:spPr>
-          <a:xfrm>
-            <a:off x="4764024" y="2807208"/>
-            <a:ext cx="1728216" cy="548640"/>
-          </a:xfrm>
-          <a:prstGeom prst="rect">
-            <a:avLst/>
-          </a:prstGeom>
-          <a:noFill/>
-          <a:ln/>
-        </p:spPr>
-        <p:txBody>
-          <a:bodyPr wrap="square" lIns="0" tIns="0" rIns="0" bIns="0" rtlCol="0" anchor="t"/>
-          <a:lstStyle/>
-          <a:p>
-            <a:pPr indent="0" marL="0">
-              <a:buNone/>
-            </a:pPr>
-            <a:r>
-              <a:rPr lang="en-US" sz="850" b="1" dirty="0">
-                <a:solidFill>
-                  <a:srgbClr val="2C5F2D"/>
-                </a:solidFill>
-                <a:latin typeface="Calibri" pitchFamily="34" charset="0"/>
-                <a:ea typeface="Calibri" pitchFamily="34" charset="-122"/>
-                <a:cs typeface="Calibri" pitchFamily="34" charset="-120"/>
-              </a:rPr>
-              <a:t>Ziel: </a:t>
-            </a:r>
-            <a:pPr indent="0" marL="0">
-              <a:buNone/>
-            </a:pPr>
-            <a:r>
-              <a:rPr lang="en-US" sz="850" dirty="0">
-                <a:solidFill>
-                  <a:srgbClr val="1F2A1F"/>
-                </a:solidFill>
-                <a:latin typeface="Calibri" pitchFamily="34" charset="0"/>
-                <a:ea typeface="Calibri" pitchFamily="34" charset="-122"/>
-                <a:cs typeface="Calibri" pitchFamily="34" charset="-120"/>
-              </a:rPr>
-              <a:t>Thema prüfen und freigeben, ohne Formular und Unterschrift</a:t>
-            </a:r>
-            <a:endParaRPr lang="en-US" sz="850" dirty="0"/>
-          </a:p>
-        </p:txBody>
-      </p:sp>
-      <p:sp>
-        <p:nvSpPr>
-          <p:cNvPr id="26" name="Text 22"/>
-          <p:cNvSpPr txBox="1"/>
-          <p:nvPr/>
-        </p:nvSpPr>
-        <p:spPr>
-          <a:xfrm>
-            <a:off x="4764024" y="3401568"/>
-            <a:ext cx="1728216" cy="548640"/>
-          </a:xfrm>
-          <a:prstGeom prst="rect">
-            <a:avLst/>
-          </a:prstGeom>
-          <a:noFill/>
-          <a:ln/>
-        </p:spPr>
-        <p:txBody>
-          <a:bodyPr wrap="square" lIns="0" tIns="0" rIns="0" bIns="0" rtlCol="0" anchor="t"/>
-          <a:lstStyle/>
-          <a:p>
-            <a:pPr indent="0" marL="0">
-              <a:buNone/>
-            </a:pPr>
-            <a:r>
-              <a:rPr lang="en-US" sz="850" b="1" dirty="0">
-                <a:solidFill>
-                  <a:srgbClr val="2C5F2D"/>
-                </a:solidFill>
-                <a:latin typeface="Calibri" pitchFamily="34" charset="0"/>
-                <a:ea typeface="Calibri" pitchFamily="34" charset="-122"/>
-                <a:cs typeface="Calibri" pitchFamily="34" charset="-120"/>
-              </a:rPr>
-              <a:t>Problem heute: </a:t>
-            </a:r>
-            <a:pPr indent="0" marL="0">
-              <a:buNone/>
-            </a:pPr>
-            <a:r>
-              <a:rPr lang="en-US" sz="850" dirty="0">
-                <a:solidFill>
-                  <a:srgbClr val="1F2A1F"/>
-                </a:solidFill>
-                <a:latin typeface="Calibri" pitchFamily="34" charset="0"/>
-                <a:ea typeface="Calibri" pitchFamily="34" charset="-122"/>
-                <a:cs typeface="Calibri" pitchFamily="34" charset="-120"/>
-              </a:rPr>
-              <a:t>Formular per E-Mail hin- und herschicken</a:t>
-            </a:r>
-            <a:endParaRPr lang="en-US" sz="850" dirty="0"/>
-          </a:p>
-        </p:txBody>
-      </p:sp>
-      <p:sp>
-        <p:nvSpPr>
-          <p:cNvPr id="27" name="Shape 23"/>
-          <p:cNvSpPr/>
-          <p:nvPr/>
-        </p:nvSpPr>
-        <p:spPr>
-          <a:xfrm>
-            <a:off x="6748272" y="932688"/>
-            <a:ext cx="1984248" cy="3063240"/>
-          </a:xfrm>
-          <a:prstGeom prst="roundRect">
-            <a:avLst>
-              <a:gd name="adj" fmla="val 3687"/>
-            </a:avLst>
-          </a:prstGeom>
-          <a:solidFill>
-            <a:srgbClr val="EEF4E8"/>
-          </a:solidFill>
-          <a:ln w="12700">
-            <a:solidFill>
-              <a:srgbClr val="EEF4E8"/>
-            </a:solidFill>
-            <a:prstDash val="solid"/>
-          </a:ln>
-        </p:spPr>
-      </p:sp>
-      <p:sp>
-        <p:nvSpPr>
-          <p:cNvPr id="28" name="Shape 24"/>
-          <p:cNvSpPr/>
-          <p:nvPr/>
-        </p:nvSpPr>
-        <p:spPr>
-          <a:xfrm>
-            <a:off x="7223760" y="1051560"/>
-            <a:ext cx="1033272" cy="1033272"/>
-          </a:xfrm>
-          <a:prstGeom prst="ellipse">
-            <a:avLst/>
-          </a:prstGeom>
-          <a:solidFill>
-            <a:srgbClr val="2C5F2D"/>
-          </a:solidFill>
-          <a:ln w="12700">
-            <a:solidFill>
-              <a:srgbClr val="2C5F2D"/>
-            </a:solidFill>
-            <a:prstDash val="solid"/>
-          </a:ln>
-        </p:spPr>
-      </p:sp>
       <p:pic>
         <p:nvPicPr>
-          <p:cNvPr id="29" name="Image 2" descr="C:\Users\Ewa\OneDrive - Aurora Engineering GmbH\ZXY\Desktop\Studium\Requirement Eng\Abschlusspräsentation\bilder\sekretariat.png">    </p:cNvPr>
+          <p:cNvPr id="22" name="Image 1" descr="C:\Users\Ewa\OneDrive - Aurora Engineering GmbH\ZXY\Desktop\Studium\Requirement Eng\Abschlusspräsentation\bilder\sekretariat.png">    </p:cNvPr>
           <p:cNvPicPr>
             <a:picLocks noChangeAspect="1"/>
           </p:cNvPicPr>
           <p:nvPr/>
         </p:nvPicPr>
         <p:blipFill>
-          <a:blip r:embed="rId3"/>
+          <a:blip r:embed="rId2"/>
           <a:stretch>
             <a:fillRect/>
           </a:stretch>
         </p:blipFill>
         <p:spPr>
           <a:xfrm>
-            <a:off x="7260336" y="1088136"/>
+            <a:off x="6903720" y="1088136"/>
             <a:ext cx="960120" cy="960120"/>
           </a:xfrm>
           <a:prstGeom prst="ellipse">
@@ -24651,14 +24391,14 @@
       </p:pic>
       <p:sp>
         <p:nvSpPr>
-          <p:cNvPr id="30" name="Text 25"/>
-          <p:cNvSpPr txBox="1"/>
-          <p:nvPr/>
-        </p:nvSpPr>
-        <p:spPr>
-          <a:xfrm>
-            <a:off x="6821424" y="2167128"/>
-            <a:ext cx="1837944" cy="274320"/>
+          <p:cNvPr id="23" name="Text 19"/>
+          <p:cNvSpPr txBox="1"/>
+          <p:nvPr/>
+        </p:nvSpPr>
+        <p:spPr>
+          <a:xfrm>
+            <a:off x="6108192" y="2167128"/>
+            <a:ext cx="2551176" cy="274320"/>
           </a:xfrm>
           <a:prstGeom prst="rect">
             <a:avLst/>
@@ -24690,14 +24430,14 @@
       </p:sp>
       <p:sp>
         <p:nvSpPr>
-          <p:cNvPr id="31" name="Text 26"/>
-          <p:cNvSpPr txBox="1"/>
-          <p:nvPr/>
-        </p:nvSpPr>
-        <p:spPr>
-          <a:xfrm>
-            <a:off x="6821424" y="2441448"/>
-            <a:ext cx="1837944" cy="310896"/>
+          <p:cNvPr id="24" name="Text 20"/>
+          <p:cNvSpPr txBox="1"/>
+          <p:nvPr/>
+        </p:nvSpPr>
+        <p:spPr>
+          <a:xfrm>
+            <a:off x="6108192" y="2441448"/>
+            <a:ext cx="2551176" cy="310896"/>
           </a:xfrm>
           <a:prstGeom prst="rect">
             <a:avLst/>
@@ -24729,14 +24469,14 @@
       </p:sp>
       <p:sp>
         <p:nvSpPr>
-          <p:cNvPr id="32" name="Text 27"/>
-          <p:cNvSpPr txBox="1"/>
-          <p:nvPr/>
-        </p:nvSpPr>
-        <p:spPr>
-          <a:xfrm>
-            <a:off x="6876288" y="2807208"/>
-            <a:ext cx="1728216" cy="548640"/>
+          <p:cNvPr id="25" name="Text 21"/>
+          <p:cNvSpPr txBox="1"/>
+          <p:nvPr/>
+        </p:nvSpPr>
+        <p:spPr>
+          <a:xfrm>
+            <a:off x="6163056" y="2807208"/>
+            <a:ext cx="2441448" cy="548640"/>
           </a:xfrm>
           <a:prstGeom prst="rect">
             <a:avLst/>
@@ -24782,14 +24522,14 @@
       </p:sp>
       <p:sp>
         <p:nvSpPr>
-          <p:cNvPr id="33" name="Text 28"/>
-          <p:cNvSpPr txBox="1"/>
-          <p:nvPr/>
-        </p:nvSpPr>
-        <p:spPr>
-          <a:xfrm>
-            <a:off x="6876288" y="3401568"/>
-            <a:ext cx="1728216" cy="548640"/>
+          <p:cNvPr id="26" name="Text 22"/>
+          <p:cNvSpPr txBox="1"/>
+          <p:nvPr/>
+        </p:nvSpPr>
+        <p:spPr>
+          <a:xfrm>
+            <a:off x="6163056" y="3401568"/>
+            <a:ext cx="2441448" cy="548640"/>
           </a:xfrm>
           <a:prstGeom prst="rect">
             <a:avLst/>
@@ -24835,7 +24575,7 @@
       </p:sp>
       <p:sp>
         <p:nvSpPr>
-          <p:cNvPr id="34" name="Shape 29"/>
+          <p:cNvPr id="27" name="Shape 23"/>
           <p:cNvSpPr/>
           <p:nvPr/>
         </p:nvSpPr>
@@ -24862,7 +24602,7 @@
       </p:sp>
       <p:sp>
         <p:nvSpPr>
-          <p:cNvPr id="35" name="Text 30"/>
+          <p:cNvPr id="28" name="Text 24"/>
           <p:cNvSpPr txBox="1"/>
           <p:nvPr/>
         </p:nvSpPr>
@@ -34274,7 +34014,7 @@
                 <a:ea typeface="Calibri" pitchFamily="34" charset="-122"/>
                 <a:cs typeface="Calibri" pitchFamily="34" charset="-120"/>
               </a:rPr>
-              <a:t>Studierende:r, B.Sc. Wirtschaftsinformatik</a:t>
+              <a:t>Studierende:r</a:t>
             </a:r>
             <a:endParaRPr lang="en-US" sz="1000" dirty="0"/>
           </a:p>

</xml_diff>